<commit_message>
latest changes in ai methodology and S3 synchro
</commit_message>
<xml_diff>
--- a/presentacion/Cursor_Presentacion.pptx
+++ b/presentacion/Cursor_Presentacion.pptx
@@ -34794,7 +34794,7 @@
                 </a:solidFill>
                 <a:latin typeface="Segoe UI"/>
               </a:rPr>
-              <a:t>Docs = fuente de verdad; grafo derivado (un publisher)</a:t>
+              <a:t>UN solo publisher. "Derivado" es del fichero, no de la carpeta</a:t>
             </a:r>
           </a:p>
         </p:txBody>
@@ -39883,7 +39883,7 @@
                 </a:solidFill>
                 <a:latin typeface="Segoe UI"/>
               </a:rPr>
-              <a:t>Recall en zonas densas · EXTRACTED = fiable, INFERRED = pista · interno (data/) · derivado: nunca viaja, se reconstruye</a:t>
+              <a:t>Recall en zonas densas · EXTRACTED = fiable, INFERRED = pista · interno (data/) · derivado se reconstruye, pero lo escrito a mano viaja</a:t>
             </a:r>
           </a:p>
         </p:txBody>

</xml_diff>